<commit_message>
docs: Fully drew Slide 7 and Slide 8 horizontal diagrams inside PowerPoint presentation
</commit_message>
<xml_diff>
--- a/BMSCE_Campus_Social_Platform_DarkBlue.pptx
+++ b/BMSCE_Campus_Social_Platform_DarkBlue.pptx
@@ -3426,9 +3426,9 @@
           <a:p>
             <a:pPr algn="ctr">
               <a:spcAft>
-                <a:spcPts val="600"/>
+                <a:spcPts val="500"/>
               </a:spcAft>
-              <a:defRPr sz="1400" b="1">
+              <a:defRPr sz="1300" b="1">
                 <a:solidFill>
                   <a:srgbClr val="00B4D8"/>
                 </a:solidFill>
@@ -3441,7 +3441,7 @@
           </a:p>
           <a:p>
             <a:pPr>
-              <a:defRPr sz="1150">
+              <a:defRPr sz="1050">
                 <a:solidFill>
                   <a:srgbClr val="FFFFFF"/>
                 </a:solidFill>
@@ -3497,9 +3497,9 @@
           <a:p>
             <a:pPr algn="ctr">
               <a:spcAft>
-                <a:spcPts val="600"/>
+                <a:spcPts val="500"/>
               </a:spcAft>
-              <a:defRPr sz="1400" b="1">
+              <a:defRPr sz="1300" b="1">
                 <a:solidFill>
                   <a:srgbClr val="00B4D8"/>
                 </a:solidFill>
@@ -3512,7 +3512,7 @@
           </a:p>
           <a:p>
             <a:pPr>
-              <a:defRPr sz="1150">
+              <a:defRPr sz="1050">
                 <a:solidFill>
                   <a:srgbClr val="FFFFFF"/>
                 </a:solidFill>
@@ -3568,9 +3568,9 @@
           <a:p>
             <a:pPr algn="ctr">
               <a:spcAft>
-                <a:spcPts val="600"/>
+                <a:spcPts val="500"/>
               </a:spcAft>
-              <a:defRPr sz="1400" b="1">
+              <a:defRPr sz="1300" b="1">
                 <a:solidFill>
                   <a:srgbClr val="00B4D8"/>
                 </a:solidFill>
@@ -3583,7 +3583,7 @@
           </a:p>
           <a:p>
             <a:pPr>
-              <a:defRPr sz="1150">
+              <a:defRPr sz="1050">
                 <a:solidFill>
                   <a:srgbClr val="FFFFFF"/>
                 </a:solidFill>
@@ -3773,9 +3773,9 @@
           <a:p>
             <a:pPr algn="ctr">
               <a:spcAft>
-                <a:spcPts val="600"/>
+                <a:spcPts val="500"/>
               </a:spcAft>
-              <a:defRPr sz="1400" b="1">
+              <a:defRPr sz="1300" b="1">
                 <a:solidFill>
                   <a:srgbClr val="FFFFFF"/>
                 </a:solidFill>
@@ -3788,7 +3788,7 @@
           </a:p>
           <a:p>
             <a:pPr>
-              <a:defRPr sz="1150">
+              <a:defRPr sz="1050">
                 <a:solidFill>
                   <a:srgbClr val="FFFFFF"/>
                 </a:solidFill>
@@ -3854,9 +3854,9 @@
           <a:p>
             <a:pPr algn="ctr">
               <a:spcAft>
-                <a:spcPts val="600"/>
+                <a:spcPts val="500"/>
               </a:spcAft>
-              <a:defRPr sz="1400" b="1">
+              <a:defRPr sz="1300" b="1">
                 <a:solidFill>
                   <a:srgbClr val="FFFFFF"/>
                 </a:solidFill>
@@ -3869,7 +3869,7 @@
           </a:p>
           <a:p>
             <a:pPr>
-              <a:defRPr sz="1150">
+              <a:defRPr sz="1050">
                 <a:solidFill>
                   <a:srgbClr val="FFFFFF"/>
                 </a:solidFill>
@@ -3935,9 +3935,9 @@
           <a:p>
             <a:pPr algn="ctr">
               <a:spcAft>
-                <a:spcPts val="600"/>
+                <a:spcPts val="500"/>
               </a:spcAft>
-              <a:defRPr sz="1400" b="1">
+              <a:defRPr sz="1300" b="1">
                 <a:solidFill>
                   <a:srgbClr val="FFFFFF"/>
                 </a:solidFill>
@@ -3950,7 +3950,7 @@
           </a:p>
           <a:p>
             <a:pPr>
-              <a:defRPr sz="1150">
+              <a:defRPr sz="1050">
                 <a:solidFill>
                   <a:srgbClr val="FFFFFF"/>
                 </a:solidFill>
@@ -4150,9 +4150,9 @@
           <a:p>
             <a:pPr algn="ctr">
               <a:spcAft>
-                <a:spcPts val="600"/>
+                <a:spcPts val="500"/>
               </a:spcAft>
-              <a:defRPr sz="1400" b="1">
+              <a:defRPr sz="1300" b="1">
                 <a:solidFill>
                   <a:srgbClr val="00B4D8"/>
                 </a:solidFill>
@@ -4165,7 +4165,7 @@
           </a:p>
           <a:p>
             <a:pPr>
-              <a:defRPr sz="1150">
+              <a:defRPr sz="1050">
                 <a:solidFill>
                   <a:srgbClr val="FFFFFF"/>
                 </a:solidFill>
@@ -4221,9 +4221,9 @@
           <a:p>
             <a:pPr algn="ctr">
               <a:spcAft>
-                <a:spcPts val="600"/>
+                <a:spcPts val="500"/>
               </a:spcAft>
-              <a:defRPr sz="1400" b="1">
+              <a:defRPr sz="1300" b="1">
                 <a:solidFill>
                   <a:srgbClr val="00B4D8"/>
                 </a:solidFill>
@@ -4236,7 +4236,7 @@
           </a:p>
           <a:p>
             <a:pPr>
-              <a:defRPr sz="1150">
+              <a:defRPr sz="1050">
                 <a:solidFill>
                   <a:srgbClr val="FFFFFF"/>
                 </a:solidFill>
@@ -4292,9 +4292,9 @@
           <a:p>
             <a:pPr algn="ctr">
               <a:spcAft>
-                <a:spcPts val="600"/>
+                <a:spcPts val="500"/>
               </a:spcAft>
-              <a:defRPr sz="1400" b="1">
+              <a:defRPr sz="1300" b="1">
                 <a:solidFill>
                   <a:srgbClr val="00B4D8"/>
                 </a:solidFill>
@@ -4307,7 +4307,7 @@
           </a:p>
           <a:p>
             <a:pPr>
-              <a:defRPr sz="1150">
+              <a:defRPr sz="1050">
                 <a:solidFill>
                   <a:srgbClr val="FFFFFF"/>
                 </a:solidFill>
@@ -4363,9 +4363,9 @@
           <a:p>
             <a:pPr algn="ctr">
               <a:spcAft>
-                <a:spcPts val="600"/>
+                <a:spcPts val="500"/>
               </a:spcAft>
-              <a:defRPr sz="1400" b="1">
+              <a:defRPr sz="1300" b="1">
                 <a:solidFill>
                   <a:srgbClr val="00B4D8"/>
                 </a:solidFill>
@@ -4378,7 +4378,7 @@
           </a:p>
           <a:p>
             <a:pPr>
-              <a:defRPr sz="1150">
+              <a:defRPr sz="1050">
                 <a:solidFill>
                   <a:srgbClr val="FFFFFF"/>
                 </a:solidFill>
@@ -4434,9 +4434,9 @@
           <a:p>
             <a:pPr algn="ctr">
               <a:spcAft>
-                <a:spcPts val="600"/>
+                <a:spcPts val="500"/>
               </a:spcAft>
-              <a:defRPr sz="1400" b="1">
+              <a:defRPr sz="1300" b="1">
                 <a:solidFill>
                   <a:srgbClr val="00B4D8"/>
                 </a:solidFill>
@@ -4449,7 +4449,7 @@
           </a:p>
           <a:p>
             <a:pPr>
-              <a:defRPr sz="1150">
+              <a:defRPr sz="1050">
                 <a:solidFill>
                   <a:srgbClr val="FFFFFF"/>
                 </a:solidFill>
@@ -4639,9 +4639,9 @@
           <a:p>
             <a:pPr algn="ctr">
               <a:spcAft>
-                <a:spcPts val="600"/>
+                <a:spcPts val="500"/>
               </a:spcAft>
-              <a:defRPr sz="1400" b="1">
+              <a:defRPr sz="1300" b="1">
                 <a:solidFill>
                   <a:srgbClr val="00B4D8"/>
                 </a:solidFill>
@@ -4654,7 +4654,7 @@
           </a:p>
           <a:p>
             <a:pPr>
-              <a:defRPr sz="1150">
+              <a:defRPr sz="1050">
                 <a:solidFill>
                   <a:srgbClr val="FFFFFF"/>
                 </a:solidFill>
@@ -4710,9 +4710,9 @@
           <a:p>
             <a:pPr algn="ctr">
               <a:spcAft>
-                <a:spcPts val="600"/>
+                <a:spcPts val="500"/>
               </a:spcAft>
-              <a:defRPr sz="1400" b="1">
+              <a:defRPr sz="1300" b="1">
                 <a:solidFill>
                   <a:srgbClr val="00B4D8"/>
                 </a:solidFill>
@@ -4725,7 +4725,7 @@
           </a:p>
           <a:p>
             <a:pPr>
-              <a:defRPr sz="1150">
+              <a:defRPr sz="1050">
                 <a:solidFill>
                   <a:srgbClr val="FFFFFF"/>
                 </a:solidFill>
@@ -4781,9 +4781,9 @@
           <a:p>
             <a:pPr algn="ctr">
               <a:spcAft>
-                <a:spcPts val="600"/>
+                <a:spcPts val="500"/>
               </a:spcAft>
-              <a:defRPr sz="1400" b="1">
+              <a:defRPr sz="1300" b="1">
                 <a:solidFill>
                   <a:srgbClr val="00B4D8"/>
                 </a:solidFill>
@@ -4796,7 +4796,7 @@
           </a:p>
           <a:p>
             <a:pPr>
-              <a:defRPr sz="1150">
+              <a:defRPr sz="1050">
                 <a:solidFill>
                   <a:srgbClr val="FFFFFF"/>
                 </a:solidFill>
@@ -4852,9 +4852,9 @@
           <a:p>
             <a:pPr algn="ctr">
               <a:spcAft>
-                <a:spcPts val="600"/>
+                <a:spcPts val="500"/>
               </a:spcAft>
-              <a:defRPr sz="1400" b="1">
+              <a:defRPr sz="1300" b="1">
                 <a:solidFill>
                   <a:srgbClr val="00B4D8"/>
                 </a:solidFill>
@@ -4867,7 +4867,7 @@
           </a:p>
           <a:p>
             <a:pPr>
-              <a:defRPr sz="1150">
+              <a:defRPr sz="1050">
                 <a:solidFill>
                   <a:srgbClr val="FFFFFF"/>
                 </a:solidFill>
@@ -5057,9 +5057,9 @@
           <a:p>
             <a:pPr algn="ctr">
               <a:spcAft>
-                <a:spcPts val="600"/>
+                <a:spcPts val="500"/>
               </a:spcAft>
-              <a:defRPr sz="1400" b="1">
+              <a:defRPr sz="1300" b="1">
                 <a:solidFill>
                   <a:srgbClr val="FFFFFF"/>
                 </a:solidFill>
@@ -5072,7 +5072,7 @@
           </a:p>
           <a:p>
             <a:pPr>
-              <a:defRPr sz="1150">
+              <a:defRPr sz="1050">
                 <a:solidFill>
                   <a:srgbClr val="FFFFFF"/>
                 </a:solidFill>
@@ -5133,9 +5133,9 @@
           <a:p>
             <a:pPr algn="ctr">
               <a:spcAft>
-                <a:spcPts val="600"/>
+                <a:spcPts val="500"/>
               </a:spcAft>
-              <a:defRPr sz="1400" b="1">
+              <a:defRPr sz="1300" b="1">
                 <a:solidFill>
                   <a:srgbClr val="FFFFFF"/>
                 </a:solidFill>
@@ -5148,7 +5148,7 @@
           </a:p>
           <a:p>
             <a:pPr>
-              <a:defRPr sz="1150">
+              <a:defRPr sz="1050">
                 <a:solidFill>
                   <a:srgbClr val="FFFFFF"/>
                 </a:solidFill>
@@ -5209,9 +5209,9 @@
           <a:p>
             <a:pPr algn="ctr">
               <a:spcAft>
-                <a:spcPts val="600"/>
+                <a:spcPts val="500"/>
               </a:spcAft>
-              <a:defRPr sz="1400" b="1">
+              <a:defRPr sz="1300" b="1">
                 <a:solidFill>
                   <a:srgbClr val="FFFFFF"/>
                 </a:solidFill>
@@ -5224,7 +5224,7 @@
           </a:p>
           <a:p>
             <a:pPr>
-              <a:defRPr sz="1150">
+              <a:defRPr sz="1050">
                 <a:solidFill>
                   <a:srgbClr val="FFFFFF"/>
                 </a:solidFill>
@@ -5542,9 +5542,9 @@
           <a:p>
             <a:pPr algn="ctr">
               <a:spcAft>
-                <a:spcPts val="600"/>
+                <a:spcPts val="500"/>
               </a:spcAft>
-              <a:defRPr sz="1400" b="1">
+              <a:defRPr sz="1300" b="1">
                 <a:solidFill>
                   <a:srgbClr val="00B4D8"/>
                 </a:solidFill>
@@ -5557,7 +5557,7 @@
           </a:p>
           <a:p>
             <a:pPr>
-              <a:defRPr sz="1150">
+              <a:defRPr sz="1050">
                 <a:solidFill>
                   <a:srgbClr val="FFFFFF"/>
                 </a:solidFill>
@@ -5617,9 +5617,9 @@
           <a:p>
             <a:pPr algn="ctr">
               <a:spcAft>
-                <a:spcPts val="600"/>
+                <a:spcPts val="500"/>
               </a:spcAft>
-              <a:defRPr sz="1400" b="1">
+              <a:defRPr sz="1300" b="1">
                 <a:solidFill>
                   <a:srgbClr val="00B4D8"/>
                 </a:solidFill>
@@ -5632,7 +5632,7 @@
           </a:p>
           <a:p>
             <a:pPr>
-              <a:defRPr sz="1150">
+              <a:defRPr sz="1050">
                 <a:solidFill>
                   <a:srgbClr val="FFFFFF"/>
                 </a:solidFill>
@@ -5826,9 +5826,9 @@
           <a:p>
             <a:pPr algn="ctr">
               <a:spcAft>
-                <a:spcPts val="600"/>
+                <a:spcPts val="500"/>
               </a:spcAft>
-              <a:defRPr sz="1400" b="1">
+              <a:defRPr sz="1300" b="1">
                 <a:solidFill>
                   <a:srgbClr val="00B4D8"/>
                 </a:solidFill>
@@ -5841,7 +5841,7 @@
           </a:p>
           <a:p>
             <a:pPr>
-              <a:defRPr sz="1150">
+              <a:defRPr sz="1050">
                 <a:solidFill>
                   <a:srgbClr val="FFFFFF"/>
                 </a:solidFill>
@@ -5897,9 +5897,9 @@
           <a:p>
             <a:pPr algn="ctr">
               <a:spcAft>
-                <a:spcPts val="600"/>
+                <a:spcPts val="500"/>
               </a:spcAft>
-              <a:defRPr sz="1400" b="1">
+              <a:defRPr sz="1300" b="1">
                 <a:solidFill>
                   <a:srgbClr val="00B4D8"/>
                 </a:solidFill>
@@ -5912,7 +5912,7 @@
           </a:p>
           <a:p>
             <a:pPr>
-              <a:defRPr sz="1150">
+              <a:defRPr sz="1050">
                 <a:solidFill>
                   <a:srgbClr val="FFFFFF"/>
                 </a:solidFill>
@@ -5968,9 +5968,9 @@
           <a:p>
             <a:pPr algn="ctr">
               <a:spcAft>
-                <a:spcPts val="600"/>
+                <a:spcPts val="500"/>
               </a:spcAft>
-              <a:defRPr sz="1400" b="1">
+              <a:defRPr sz="1300" b="1">
                 <a:solidFill>
                   <a:srgbClr val="00B4D8"/>
                 </a:solidFill>
@@ -5983,7 +5983,7 @@
           </a:p>
           <a:p>
             <a:pPr>
-              <a:defRPr sz="1150">
+              <a:defRPr sz="1050">
                 <a:solidFill>
                   <a:srgbClr val="FFFFFF"/>
                 </a:solidFill>
@@ -6039,9 +6039,9 @@
           <a:p>
             <a:pPr algn="ctr">
               <a:spcAft>
-                <a:spcPts val="600"/>
+                <a:spcPts val="500"/>
               </a:spcAft>
-              <a:defRPr sz="1400" b="1">
+              <a:defRPr sz="1300" b="1">
                 <a:solidFill>
                   <a:srgbClr val="00B4D8"/>
                 </a:solidFill>
@@ -6054,7 +6054,7 @@
           </a:p>
           <a:p>
             <a:pPr>
-              <a:defRPr sz="1150">
+              <a:defRPr sz="1050">
                 <a:solidFill>
                   <a:srgbClr val="FFFFFF"/>
                 </a:solidFill>
@@ -6110,9 +6110,9 @@
           <a:p>
             <a:pPr algn="ctr">
               <a:spcAft>
-                <a:spcPts val="600"/>
+                <a:spcPts val="500"/>
               </a:spcAft>
-              <a:defRPr sz="1400" b="1">
+              <a:defRPr sz="1300" b="1">
                 <a:solidFill>
                   <a:srgbClr val="00B4D8"/>
                 </a:solidFill>
@@ -6125,7 +6125,7 @@
           </a:p>
           <a:p>
             <a:pPr>
-              <a:defRPr sz="1150">
+              <a:defRPr sz="1050">
                 <a:solidFill>
                   <a:srgbClr val="FFFFFF"/>
                 </a:solidFill>
@@ -6315,9 +6315,9 @@
           <a:p>
             <a:pPr algn="ctr">
               <a:spcAft>
-                <a:spcPts val="600"/>
+                <a:spcPts val="500"/>
               </a:spcAft>
-              <a:defRPr sz="1400" b="1">
+              <a:defRPr sz="1300" b="1">
                 <a:solidFill>
                   <a:srgbClr val="00B4D8"/>
                 </a:solidFill>
@@ -6330,7 +6330,7 @@
           </a:p>
           <a:p>
             <a:pPr>
-              <a:defRPr sz="1150">
+              <a:defRPr sz="1050">
                 <a:solidFill>
                   <a:srgbClr val="FFFFFF"/>
                 </a:solidFill>
@@ -6386,9 +6386,9 @@
           <a:p>
             <a:pPr algn="ctr">
               <a:spcAft>
-                <a:spcPts val="600"/>
+                <a:spcPts val="500"/>
               </a:spcAft>
-              <a:defRPr sz="1400" b="1">
+              <a:defRPr sz="1300" b="1">
                 <a:solidFill>
                   <a:srgbClr val="00B4D8"/>
                 </a:solidFill>
@@ -6401,7 +6401,7 @@
           </a:p>
           <a:p>
             <a:pPr>
-              <a:defRPr sz="1150">
+              <a:defRPr sz="1050">
                 <a:solidFill>
                   <a:srgbClr val="FFFFFF"/>
                 </a:solidFill>
@@ -6457,9 +6457,9 @@
           <a:p>
             <a:pPr algn="ctr">
               <a:spcAft>
-                <a:spcPts val="600"/>
+                <a:spcPts val="500"/>
               </a:spcAft>
-              <a:defRPr sz="1400" b="1">
+              <a:defRPr sz="1300" b="1">
                 <a:solidFill>
                   <a:srgbClr val="00B4D8"/>
                 </a:solidFill>
@@ -6472,7 +6472,7 @@
           </a:p>
           <a:p>
             <a:pPr>
-              <a:defRPr sz="1150">
+              <a:defRPr sz="1050">
                 <a:solidFill>
                   <a:srgbClr val="FFFFFF"/>
                 </a:solidFill>
@@ -6717,9 +6717,9 @@
           <a:p>
             <a:pPr algn="ctr">
               <a:spcAft>
-                <a:spcPts val="600"/>
+                <a:spcPts val="500"/>
               </a:spcAft>
-              <a:defRPr sz="1400" b="1">
+              <a:defRPr sz="1300" b="1">
                 <a:solidFill>
                   <a:srgbClr val="00B4D8"/>
                 </a:solidFill>
@@ -6732,7 +6732,7 @@
           </a:p>
           <a:p>
             <a:pPr>
-              <a:defRPr sz="1150">
+              <a:defRPr sz="1050">
                 <a:solidFill>
                   <a:srgbClr val="FFFFFF"/>
                 </a:solidFill>
@@ -6788,9 +6788,9 @@
           <a:p>
             <a:pPr algn="ctr">
               <a:spcAft>
-                <a:spcPts val="600"/>
+                <a:spcPts val="500"/>
               </a:spcAft>
-              <a:defRPr sz="1400" b="1">
+              <a:defRPr sz="1300" b="1">
                 <a:solidFill>
                   <a:srgbClr val="00B4D8"/>
                 </a:solidFill>
@@ -6803,7 +6803,7 @@
           </a:p>
           <a:p>
             <a:pPr>
-              <a:defRPr sz="1150">
+              <a:defRPr sz="1050">
                 <a:solidFill>
                   <a:srgbClr val="FFFFFF"/>
                 </a:solidFill>
@@ -6859,9 +6859,9 @@
           <a:p>
             <a:pPr algn="ctr">
               <a:spcAft>
-                <a:spcPts val="600"/>
+                <a:spcPts val="500"/>
               </a:spcAft>
-              <a:defRPr sz="1400" b="1">
+              <a:defRPr sz="1300" b="1">
                 <a:solidFill>
                   <a:srgbClr val="00B4D8"/>
                 </a:solidFill>
@@ -6874,7 +6874,7 @@
           </a:p>
           <a:p>
             <a:pPr>
-              <a:defRPr sz="1150">
+              <a:defRPr sz="1050">
                 <a:solidFill>
                   <a:srgbClr val="FFFFFF"/>
                 </a:solidFill>
@@ -6930,9 +6930,9 @@
           <a:p>
             <a:pPr algn="ctr">
               <a:spcAft>
-                <a:spcPts val="600"/>
+                <a:spcPts val="500"/>
               </a:spcAft>
-              <a:defRPr sz="1400" b="1">
+              <a:defRPr sz="1300" b="1">
                 <a:solidFill>
                   <a:srgbClr val="00B4D8"/>
                 </a:solidFill>
@@ -6945,7 +6945,7 @@
           </a:p>
           <a:p>
             <a:pPr>
-              <a:defRPr sz="1150">
+              <a:defRPr sz="1050">
                 <a:solidFill>
                   <a:srgbClr val="FFFFFF"/>
                 </a:solidFill>
@@ -7190,9 +7190,9 @@
           <a:p>
             <a:pPr algn="ctr">
               <a:spcAft>
-                <a:spcPts val="600"/>
+                <a:spcPts val="500"/>
               </a:spcAft>
-              <a:defRPr sz="1400" b="1">
+              <a:defRPr sz="1300" b="1">
                 <a:solidFill>
                   <a:srgbClr val="00B4D8"/>
                 </a:solidFill>
@@ -7205,7 +7205,7 @@
           </a:p>
           <a:p>
             <a:pPr>
-              <a:defRPr sz="1150">
+              <a:defRPr sz="1050">
                 <a:solidFill>
                   <a:srgbClr val="FFFFFF"/>
                 </a:solidFill>
@@ -7261,9 +7261,9 @@
           <a:p>
             <a:pPr algn="ctr">
               <a:spcAft>
-                <a:spcPts val="600"/>
+                <a:spcPts val="500"/>
               </a:spcAft>
-              <a:defRPr sz="1400" b="1">
+              <a:defRPr sz="1300" b="1">
                 <a:solidFill>
                   <a:srgbClr val="00B4D8"/>
                 </a:solidFill>
@@ -7276,7 +7276,7 @@
           </a:p>
           <a:p>
             <a:pPr>
-              <a:defRPr sz="1150">
+              <a:defRPr sz="1050">
                 <a:solidFill>
                   <a:srgbClr val="FFFFFF"/>
                 </a:solidFill>
@@ -7332,9 +7332,9 @@
           <a:p>
             <a:pPr algn="ctr">
               <a:spcAft>
-                <a:spcPts val="600"/>
+                <a:spcPts val="500"/>
               </a:spcAft>
-              <a:defRPr sz="1400" b="1">
+              <a:defRPr sz="1300" b="1">
                 <a:solidFill>
                   <a:srgbClr val="00B4D8"/>
                 </a:solidFill>
@@ -7347,7 +7347,7 @@
           </a:p>
           <a:p>
             <a:pPr>
-              <a:defRPr sz="1150">
+              <a:defRPr sz="1050">
                 <a:solidFill>
                   <a:srgbClr val="FFFFFF"/>
                 </a:solidFill>
@@ -7403,9 +7403,9 @@
           <a:p>
             <a:pPr algn="ctr">
               <a:spcAft>
-                <a:spcPts val="600"/>
+                <a:spcPts val="500"/>
               </a:spcAft>
-              <a:defRPr sz="1400" b="1">
+              <a:defRPr sz="1300" b="1">
                 <a:solidFill>
                   <a:srgbClr val="00B4D8"/>
                 </a:solidFill>
@@ -7418,7 +7418,7 @@
           </a:p>
           <a:p>
             <a:pPr>
-              <a:defRPr sz="1150">
+              <a:defRPr sz="1050">
                 <a:solidFill>
                   <a:srgbClr val="FFFFFF"/>
                 </a:solidFill>
@@ -7628,8 +7628,8 @@
         </p:nvSpPr>
         <p:spPr>
           <a:xfrm>
-            <a:off x="731520" y="1645920"/>
-            <a:ext cx="5120640" cy="1051560"/>
+            <a:off x="731520" y="2560320"/>
+            <a:ext cx="1691640" cy="2194560"/>
           </a:xfrm>
           <a:prstGeom prst="roundRect">
             <a:avLst/>
@@ -7663,9 +7663,9 @@
           <a:p>
             <a:pPr algn="ctr">
               <a:spcAft>
-                <a:spcPts val="600"/>
+                <a:spcPts val="500"/>
               </a:spcAft>
-              <a:defRPr sz="1400" b="1">
+              <a:defRPr sz="1300" b="1">
                 <a:solidFill>
                   <a:srgbClr val="00B4D8"/>
                 </a:solidFill>
@@ -7673,12 +7673,12 @@
               </a:defRPr>
             </a:pPr>
             <a:r>
-              <a:t>Frontend (Vercel Host)</a:t>
+              <a:t>📱 Client Tier</a:t>
             </a:r>
           </a:p>
           <a:p>
             <a:pPr>
-              <a:defRPr sz="1150">
+              <a:defRPr sz="1050">
                 <a:solidFill>
                   <a:srgbClr val="FFFFFF"/>
                 </a:solidFill>
@@ -7686,21 +7686,82 @@
               </a:defRPr>
             </a:pPr>
             <a:r>
-              <a:t>Next.js App Router loaded locally on client viewports. Caches assets for offline capability.</a:t>
-            </a:r>
-          </a:p>
-        </p:txBody>
-      </p:sp>
-      <p:sp>
-        <p:nvSpPr>
-          <p:cNvPr id="6" name="Rounded Rectangle 5"/>
+              <a:t>Next.js 14 / React</a:t>
+            </a:r>
+            <a:br/>
+            <a:r>
+              <a:t>• Responsive layouts</a:t>
+            </a:r>
+            <a:br/>
+            <a:r>
+              <a:t>• Caches views locally</a:t>
+            </a:r>
+            <a:br/>
+            <a:r>
+              <a:t>• Offline-first queueing</a:t>
+            </a:r>
+            <a:br/>
+            <a:r>
+              <a:t>• Hosted on Vercel</a:t>
+            </a:r>
+          </a:p>
+        </p:txBody>
+      </p:sp>
+      <p:sp>
+        <p:nvSpPr>
+          <p:cNvPr id="6" name="Right Arrow 5"/>
           <p:cNvSpPr/>
           <p:nvPr/>
         </p:nvSpPr>
         <p:spPr>
           <a:xfrm>
-            <a:off x="731520" y="2788920"/>
-            <a:ext cx="5120640" cy="1051560"/>
+            <a:off x="2423160" y="3429000"/>
+            <a:ext cx="411480" cy="457200"/>
+          </a:xfrm>
+          <a:prstGeom prst="rightArrow">
+            <a:avLst/>
+          </a:prstGeom>
+          <a:solidFill>
+            <a:srgbClr val="00B4D8"/>
+          </a:solidFill>
+          <a:ln w="12700">
+            <a:solidFill>
+              <a:srgbClr val="00B4D8"/>
+            </a:solidFill>
+          </a:ln>
+        </p:spPr>
+        <p:style>
+          <a:lnRef idx="1">
+            <a:schemeClr val="accent1"/>
+          </a:lnRef>
+          <a:fillRef idx="3">
+            <a:schemeClr val="accent1"/>
+          </a:fillRef>
+          <a:effectRef idx="2">
+            <a:schemeClr val="accent1"/>
+          </a:effectRef>
+          <a:fontRef idx="minor">
+            <a:schemeClr val="lt1"/>
+          </a:fontRef>
+        </p:style>
+        <p:txBody>
+          <a:bodyPr rtlCol="0" anchor="ctr"/>
+          <a:lstStyle/>
+          <a:p>
+            <a:pPr algn="ctr"/>
+          </a:p>
+        </p:txBody>
+      </p:sp>
+      <p:sp>
+        <p:nvSpPr>
+          <p:cNvPr id="7" name="Rounded Rectangle 6"/>
+          <p:cNvSpPr/>
+          <p:nvPr/>
+        </p:nvSpPr>
+        <p:spPr>
+          <a:xfrm>
+            <a:off x="2834640" y="2560320"/>
+            <a:ext cx="1691640" cy="2194560"/>
           </a:xfrm>
           <a:prstGeom prst="roundRect">
             <a:avLst/>
@@ -7734,9 +7795,9 @@
           <a:p>
             <a:pPr algn="ctr">
               <a:spcAft>
-                <a:spcPts val="600"/>
+                <a:spcPts val="500"/>
               </a:spcAft>
-              <a:defRPr sz="1400" b="1">
+              <a:defRPr sz="1300" b="1">
                 <a:solidFill>
                   <a:srgbClr val="00B4D8"/>
                 </a:solidFill>
@@ -7744,12 +7805,12 @@
               </a:defRPr>
             </a:pPr>
             <a:r>
-              <a:t>REST API Server (Render Host)</a:t>
+              <a:t>⚙️ Express API</a:t>
             </a:r>
           </a:p>
           <a:p>
             <a:pPr>
-              <a:defRPr sz="1150">
+              <a:defRPr sz="1050">
                 <a:solidFill>
                   <a:srgbClr val="FFFFFF"/>
                 </a:solidFill>
@@ -7757,21 +7818,82 @@
               </a:defRPr>
             </a:pPr>
             <a:r>
-              <a:t>Node/Express endpoint handling geofence coordinates checks and messaging gateways.</a:t>
-            </a:r>
-          </a:p>
-        </p:txBody>
-      </p:sp>
-      <p:sp>
-        <p:nvSpPr>
-          <p:cNvPr id="7" name="Rounded Rectangle 6"/>
+              <a:t>Node.js Middleware</a:t>
+            </a:r>
+            <a:br/>
+            <a:r>
+              <a:t>• Validates coordinates</a:t>
+            </a:r>
+            <a:br/>
+            <a:r>
+              <a:t>• Checks checkin streaks</a:t>
+            </a:r>
+            <a:br/>
+            <a:r>
+              <a:t>• Routes direct messages</a:t>
+            </a:r>
+            <a:br/>
+            <a:r>
+              <a:t>• Hosted on Render</a:t>
+            </a:r>
+          </a:p>
+        </p:txBody>
+      </p:sp>
+      <p:sp>
+        <p:nvSpPr>
+          <p:cNvPr id="8" name="Right Arrow 7"/>
           <p:cNvSpPr/>
           <p:nvPr/>
         </p:nvSpPr>
         <p:spPr>
           <a:xfrm>
-            <a:off x="731520" y="3931920"/>
-            <a:ext cx="5120640" cy="1051560"/>
+            <a:off x="4526280" y="3429000"/>
+            <a:ext cx="411480" cy="457200"/>
+          </a:xfrm>
+          <a:prstGeom prst="rightArrow">
+            <a:avLst/>
+          </a:prstGeom>
+          <a:solidFill>
+            <a:srgbClr val="00B4D8"/>
+          </a:solidFill>
+          <a:ln w="12700">
+            <a:solidFill>
+              <a:srgbClr val="00B4D8"/>
+            </a:solidFill>
+          </a:ln>
+        </p:spPr>
+        <p:style>
+          <a:lnRef idx="1">
+            <a:schemeClr val="accent1"/>
+          </a:lnRef>
+          <a:fillRef idx="3">
+            <a:schemeClr val="accent1"/>
+          </a:fillRef>
+          <a:effectRef idx="2">
+            <a:schemeClr val="accent1"/>
+          </a:effectRef>
+          <a:fontRef idx="minor">
+            <a:schemeClr val="lt1"/>
+          </a:fontRef>
+        </p:style>
+        <p:txBody>
+          <a:bodyPr rtlCol="0" anchor="ctr"/>
+          <a:lstStyle/>
+          <a:p>
+            <a:pPr algn="ctr"/>
+          </a:p>
+        </p:txBody>
+      </p:sp>
+      <p:sp>
+        <p:nvSpPr>
+          <p:cNvPr id="9" name="Rounded Rectangle 8"/>
+          <p:cNvSpPr/>
+          <p:nvPr/>
+        </p:nvSpPr>
+        <p:spPr>
+          <a:xfrm>
+            <a:off x="4937760" y="2560320"/>
+            <a:ext cx="1691640" cy="2194560"/>
           </a:xfrm>
           <a:prstGeom prst="roundRect">
             <a:avLst/>
@@ -7805,9 +7927,9 @@
           <a:p>
             <a:pPr algn="ctr">
               <a:spcAft>
-                <a:spcPts val="600"/>
+                <a:spcPts val="500"/>
               </a:spcAft>
-              <a:defRPr sz="1400" b="1">
+              <a:defRPr sz="1300" b="1">
                 <a:solidFill>
                   <a:srgbClr val="00B4D8"/>
                 </a:solidFill>
@@ -7815,12 +7937,12 @@
               </a:defRPr>
             </a:pPr>
             <a:r>
-              <a:t>NoSQL Database (Google Firestore)</a:t>
+              <a:t>🔥 Cloud Storage</a:t>
             </a:r>
           </a:p>
           <a:p>
             <a:pPr>
-              <a:defRPr sz="1150">
+              <a:defRPr sz="1050">
                 <a:solidFill>
                   <a:srgbClr val="FFFFFF"/>
                 </a:solidFill>
@@ -7828,21 +7950,82 @@
               </a:defRPr>
             </a:pPr>
             <a:r>
-              <a:t>Stores student profiles, chat logs, stamps, and coordinates as document schemas.</a:t>
-            </a:r>
-          </a:p>
-        </p:txBody>
-      </p:sp>
-      <p:sp>
-        <p:nvSpPr>
-          <p:cNvPr id="8" name="Rounded Rectangle 7"/>
+              <a:t>Google Firestore</a:t>
+            </a:r>
+            <a:br/>
+            <a:r>
+              <a:t>• JSON Document DBs</a:t>
+            </a:r>
+            <a:br/>
+            <a:r>
+              <a:t>• Firebase Auth checks</a:t>
+            </a:r>
+            <a:br/>
+            <a:r>
+              <a:t>• Cloudinary photo hosts</a:t>
+            </a:r>
+            <a:br/>
+            <a:r>
+              <a:t>• Serverless scaling</a:t>
+            </a:r>
+          </a:p>
+        </p:txBody>
+      </p:sp>
+      <p:sp>
+        <p:nvSpPr>
+          <p:cNvPr id="10" name="Right Arrow 9"/>
           <p:cNvSpPr/>
           <p:nvPr/>
         </p:nvSpPr>
         <p:spPr>
           <a:xfrm>
-            <a:off x="731520" y="5074920"/>
-            <a:ext cx="5120640" cy="1051560"/>
+            <a:off x="6629400" y="3429000"/>
+            <a:ext cx="411480" cy="457200"/>
+          </a:xfrm>
+          <a:prstGeom prst="rightArrow">
+            <a:avLst/>
+          </a:prstGeom>
+          <a:solidFill>
+            <a:srgbClr val="00B4D8"/>
+          </a:solidFill>
+          <a:ln w="12700">
+            <a:solidFill>
+              <a:srgbClr val="00B4D8"/>
+            </a:solidFill>
+          </a:ln>
+        </p:spPr>
+        <p:style>
+          <a:lnRef idx="1">
+            <a:schemeClr val="accent1"/>
+          </a:lnRef>
+          <a:fillRef idx="3">
+            <a:schemeClr val="accent1"/>
+          </a:fillRef>
+          <a:effectRef idx="2">
+            <a:schemeClr val="accent1"/>
+          </a:effectRef>
+          <a:fontRef idx="minor">
+            <a:schemeClr val="lt1"/>
+          </a:fontRef>
+        </p:style>
+        <p:txBody>
+          <a:bodyPr rtlCol="0" anchor="ctr"/>
+          <a:lstStyle/>
+          <a:p>
+            <a:pPr algn="ctr"/>
+          </a:p>
+        </p:txBody>
+      </p:sp>
+      <p:sp>
+        <p:nvSpPr>
+          <p:cNvPr id="11" name="Rounded Rectangle 10"/>
+          <p:cNvSpPr/>
+          <p:nvPr/>
+        </p:nvSpPr>
+        <p:spPr>
+          <a:xfrm>
+            <a:off x="7040880" y="2560320"/>
+            <a:ext cx="1691640" cy="2194560"/>
           </a:xfrm>
           <a:prstGeom prst="roundRect">
             <a:avLst/>
@@ -7876,9 +8059,9 @@
           <a:p>
             <a:pPr algn="ctr">
               <a:spcAft>
-                <a:spcPts val="600"/>
+                <a:spcPts val="500"/>
               </a:spcAft>
-              <a:defRPr sz="1400" b="1">
+              <a:defRPr sz="1300" b="1">
                 <a:solidFill>
                   <a:srgbClr val="00B4D8"/>
                 </a:solidFill>
@@ -7886,12 +8069,12 @@
               </a:defRPr>
             </a:pPr>
             <a:r>
-              <a:t>File Host (Cloudinary CDN)</a:t>
+              <a:t>🌊 Data Lake</a:t>
             </a:r>
           </a:p>
           <a:p>
             <a:pPr>
-              <a:defRPr sz="1150">
+              <a:defRPr sz="1050">
                 <a:solidFill>
                   <a:srgbClr val="FFFFFF"/>
                 </a:solidFill>
@@ -7899,29 +8082,45 @@
               </a:defRPr>
             </a:pPr>
             <a:r>
-              <a:t>Compresses and stores student scan uploads globally for mobile load speeds.</a:t>
-            </a:r>
-          </a:p>
-        </p:txBody>
-      </p:sp>
-      <p:sp>
-        <p:nvSpPr>
-          <p:cNvPr id="9" name="Rounded Rectangle 8"/>
+              <a:t>GCS / Delta Lake</a:t>
+            </a:r>
+            <a:br/>
+            <a:r>
+              <a:t>• Sync extension exports</a:t>
+            </a:r>
+            <a:br/>
+            <a:r>
+              <a:t>• Stores daily updates</a:t>
+            </a:r>
+            <a:br/>
+            <a:r>
+              <a:t>• Mounted as Delta tables</a:t>
+            </a:r>
+            <a:br/>
+            <a:r>
+              <a:t>• Google Storage host</a:t>
+            </a:r>
+          </a:p>
+        </p:txBody>
+      </p:sp>
+      <p:sp>
+        <p:nvSpPr>
+          <p:cNvPr id="12" name="Right Arrow 11"/>
           <p:cNvSpPr/>
           <p:nvPr/>
         </p:nvSpPr>
         <p:spPr>
           <a:xfrm>
-            <a:off x="6309360" y="1645920"/>
-            <a:ext cx="5120640" cy="4480560"/>
-          </a:xfrm>
-          <a:prstGeom prst="roundRect">
+            <a:off x="8732520" y="3429000"/>
+            <a:ext cx="411480" cy="457200"/>
+          </a:xfrm>
+          <a:prstGeom prst="rightArrow">
             <a:avLst/>
           </a:prstGeom>
           <a:solidFill>
-            <a:srgbClr val="101D30"/>
+            <a:srgbClr val="00B4D8"/>
           </a:solidFill>
-          <a:ln w="19050">
+          <a:ln w="12700">
             <a:solidFill>
               <a:srgbClr val="00B4D8"/>
             </a:solidFill>
@@ -7942,19 +8141,96 @@
           </a:fontRef>
         </p:style>
         <p:txBody>
-          <a:bodyPr rtlCol="0" anchor="ctr" wrap="square"/>
+          <a:bodyPr rtlCol="0" anchor="ctr"/>
+          <a:lstStyle/>
+          <a:p>
+            <a:pPr algn="ctr"/>
+          </a:p>
+        </p:txBody>
+      </p:sp>
+      <p:sp>
+        <p:nvSpPr>
+          <p:cNvPr id="13" name="Rounded Rectangle 12"/>
+          <p:cNvSpPr/>
+          <p:nvPr/>
+        </p:nvSpPr>
+        <p:spPr>
+          <a:xfrm>
+            <a:off x="9144000" y="2560320"/>
+            <a:ext cx="2286000" cy="2194560"/>
+          </a:xfrm>
+          <a:prstGeom prst="roundRect">
+            <a:avLst/>
+          </a:prstGeom>
+          <a:solidFill>
+            <a:srgbClr val="162438"/>
+          </a:solidFill>
+          <a:ln w="19050">
+            <a:solidFill>
+              <a:srgbClr val="263852"/>
+            </a:solidFill>
+          </a:ln>
+        </p:spPr>
+        <p:style>
+          <a:lnRef idx="1">
+            <a:schemeClr val="accent1"/>
+          </a:lnRef>
+          <a:fillRef idx="3">
+            <a:schemeClr val="accent1"/>
+          </a:fillRef>
+          <a:effectRef idx="2">
+            <a:schemeClr val="accent1"/>
+          </a:effectRef>
+          <a:fontRef idx="minor">
+            <a:schemeClr val="lt1"/>
+          </a:fontRef>
+        </p:style>
+        <p:txBody>
+          <a:bodyPr rtlCol="0" anchor="ctr" wrap="square" lIns="228600" rIns="228600" tIns="182880" bIns="182880"/>
           <a:lstStyle/>
           <a:p>
             <a:pPr algn="ctr">
-              <a:defRPr sz="1200" b="1">
-                <a:solidFill>
-                  <a:srgbClr val="BEC8DA"/>
-                </a:solidFill>
-                <a:latin typeface="Arial"/>
-              </a:defRPr>
-            </a:pPr>
-            <a:r>
-              <a:t>[ ARCHITECTURE DIAGRAM: FRONTEND / API / STORAGE / CLOUD ]</a:t>
+              <a:spcAft>
+                <a:spcPts val="500"/>
+              </a:spcAft>
+              <a:defRPr sz="1300" b="1">
+                <a:solidFill>
+                  <a:srgbClr val="00B4D8"/>
+                </a:solidFill>
+                <a:latin typeface="Arial"/>
+              </a:defRPr>
+            </a:pPr>
+            <a:r>
+              <a:t>🧠 Analytics</a:t>
+            </a:r>
+          </a:p>
+          <a:p>
+            <a:pPr>
+              <a:defRPr sz="1050">
+                <a:solidFill>
+                  <a:srgbClr val="FFFFFF"/>
+                </a:solidFill>
+                <a:latin typeface="Arial"/>
+              </a:defRPr>
+            </a:pPr>
+            <a:r>
+              <a:t>Databricks Genie CE</a:t>
+            </a:r>
+            <a:br/>
+            <a:r>
+              <a:t>• Natural language inputs</a:t>
+            </a:r>
+            <a:br/>
+            <a:r>
+              <a:t>• Auto-SQL translation</a:t>
+            </a:r>
+            <a:br/>
+            <a:r>
+              <a:t>• Renders traffic maps</a:t>
+            </a:r>
+            <a:br/>
+            <a:r>
+              <a:t>• Real-time admin views</a:t>
             </a:r>
           </a:p>
         </p:txBody>
@@ -8101,8 +8377,8 @@
         </p:nvSpPr>
         <p:spPr>
           <a:xfrm>
-            <a:off x="731520" y="1645920"/>
-            <a:ext cx="5120640" cy="1371600"/>
+            <a:off x="731520" y="2560320"/>
+            <a:ext cx="2011680" cy="2194560"/>
           </a:xfrm>
           <a:prstGeom prst="roundRect">
             <a:avLst/>
@@ -8136,9 +8412,9 @@
           <a:p>
             <a:pPr algn="ctr">
               <a:spcAft>
-                <a:spcPts val="600"/>
+                <a:spcPts val="500"/>
               </a:spcAft>
-              <a:defRPr sz="1400" b="1">
+              <a:defRPr sz="1300" b="1">
                 <a:solidFill>
                   <a:srgbClr val="00B4D8"/>
                 </a:solidFill>
@@ -8146,12 +8422,12 @@
               </a:defRPr>
             </a:pPr>
             <a:r>
-              <a:t>Location Scanning Pipeline</a:t>
+              <a:t>📸 1. Capture &amp; Scan</a:t>
             </a:r>
           </a:p>
           <a:p>
             <a:pPr>
-              <a:defRPr sz="1150">
+              <a:defRPr sz="1050">
                 <a:solidFill>
                   <a:srgbClr val="FFFFFF"/>
                 </a:solidFill>
@@ -8159,21 +8435,66 @@
               </a:defRPr>
             </a:pPr>
             <a:r>
-              <a:t>Camera Upload -&gt; API uploads to Cloudinary -&gt; API checks location databases -&gt; Firestore logs stamp -&gt; Client unlocks Map Tile.</a:t>
-            </a:r>
-          </a:p>
-        </p:txBody>
-      </p:sp>
-      <p:sp>
-        <p:nvSpPr>
-          <p:cNvPr id="6" name="Rounded Rectangle 5"/>
+              <a:t>Student takes a campus landmark photo. The Next.js client attaches GPS metadata and dispatches it securely to the Node server.</a:t>
+            </a:r>
+          </a:p>
+        </p:txBody>
+      </p:sp>
+      <p:sp>
+        <p:nvSpPr>
+          <p:cNvPr id="6" name="Right Arrow 5"/>
           <p:cNvSpPr/>
           <p:nvPr/>
         </p:nvSpPr>
         <p:spPr>
           <a:xfrm>
-            <a:off x="731520" y="3200400"/>
-            <a:ext cx="5120640" cy="1371600"/>
+            <a:off x="2743200" y="3429000"/>
+            <a:ext cx="502920" cy="457200"/>
+          </a:xfrm>
+          <a:prstGeom prst="rightArrow">
+            <a:avLst/>
+          </a:prstGeom>
+          <a:solidFill>
+            <a:srgbClr val="00B4D8"/>
+          </a:solidFill>
+          <a:ln w="12700">
+            <a:solidFill>
+              <a:srgbClr val="00B4D8"/>
+            </a:solidFill>
+          </a:ln>
+        </p:spPr>
+        <p:style>
+          <a:lnRef idx="1">
+            <a:schemeClr val="accent1"/>
+          </a:lnRef>
+          <a:fillRef idx="3">
+            <a:schemeClr val="accent1"/>
+          </a:fillRef>
+          <a:effectRef idx="2">
+            <a:schemeClr val="accent1"/>
+          </a:effectRef>
+          <a:fontRef idx="minor">
+            <a:schemeClr val="lt1"/>
+          </a:fontRef>
+        </p:style>
+        <p:txBody>
+          <a:bodyPr rtlCol="0" anchor="ctr"/>
+          <a:lstStyle/>
+          <a:p>
+            <a:pPr algn="ctr"/>
+          </a:p>
+        </p:txBody>
+      </p:sp>
+      <p:sp>
+        <p:nvSpPr>
+          <p:cNvPr id="7" name="Rounded Rectangle 6"/>
+          <p:cNvSpPr/>
+          <p:nvPr/>
+        </p:nvSpPr>
+        <p:spPr>
+          <a:xfrm>
+            <a:off x="3246120" y="2560320"/>
+            <a:ext cx="2011680" cy="2194560"/>
           </a:xfrm>
           <a:prstGeom prst="roundRect">
             <a:avLst/>
@@ -8207,9 +8528,9 @@
           <a:p>
             <a:pPr algn="ctr">
               <a:spcAft>
-                <a:spcPts val="600"/>
+                <a:spcPts val="500"/>
               </a:spcAft>
-              <a:defRPr sz="1400" b="1">
+              <a:defRPr sz="1300" b="1">
                 <a:solidFill>
                   <a:srgbClr val="00B4D8"/>
                 </a:solidFill>
@@ -8217,12 +8538,12 @@
               </a:defRPr>
             </a:pPr>
             <a:r>
-              <a:t>Explore Streak Calculation</a:t>
+              <a:t>📦 2. Host &amp; Save</a:t>
             </a:r>
           </a:p>
           <a:p>
             <a:pPr>
-              <a:defRPr sz="1150">
+              <a:defRPr sz="1050">
                 <a:solidFill>
                   <a:srgbClr val="FFFFFF"/>
                 </a:solidFill>
@@ -8230,21 +8551,66 @@
               </a:defRPr>
             </a:pPr>
             <a:r>
-              <a:t>Client logs scan -&gt; Server checks lastScanDate -&gt; if equal to 1 day, increments streak and awards +25 XP streak bonus.</a:t>
-            </a:r>
-          </a:p>
-        </p:txBody>
-      </p:sp>
-      <p:sp>
-        <p:nvSpPr>
-          <p:cNvPr id="7" name="Rounded Rectangle 6"/>
+              <a:t>Node server uploads the photo to Cloudinary. Once complete, it saves the optimized HTTPS image URL to Google Firestore.</a:t>
+            </a:r>
+          </a:p>
+        </p:txBody>
+      </p:sp>
+      <p:sp>
+        <p:nvSpPr>
+          <p:cNvPr id="8" name="Right Arrow 7"/>
           <p:cNvSpPr/>
           <p:nvPr/>
         </p:nvSpPr>
         <p:spPr>
           <a:xfrm>
-            <a:off x="731520" y="4754880"/>
-            <a:ext cx="5120640" cy="1371600"/>
+            <a:off x="5257800" y="3429000"/>
+            <a:ext cx="502920" cy="457200"/>
+          </a:xfrm>
+          <a:prstGeom prst="rightArrow">
+            <a:avLst/>
+          </a:prstGeom>
+          <a:solidFill>
+            <a:srgbClr val="00B4D8"/>
+          </a:solidFill>
+          <a:ln w="12700">
+            <a:solidFill>
+              <a:srgbClr val="00B4D8"/>
+            </a:solidFill>
+          </a:ln>
+        </p:spPr>
+        <p:style>
+          <a:lnRef idx="1">
+            <a:schemeClr val="accent1"/>
+          </a:lnRef>
+          <a:fillRef idx="3">
+            <a:schemeClr val="accent1"/>
+          </a:fillRef>
+          <a:effectRef idx="2">
+            <a:schemeClr val="accent1"/>
+          </a:effectRef>
+          <a:fontRef idx="minor">
+            <a:schemeClr val="lt1"/>
+          </a:fontRef>
+        </p:style>
+        <p:txBody>
+          <a:bodyPr rtlCol="0" anchor="ctr"/>
+          <a:lstStyle/>
+          <a:p>
+            <a:pPr algn="ctr"/>
+          </a:p>
+        </p:txBody>
+      </p:sp>
+      <p:sp>
+        <p:nvSpPr>
+          <p:cNvPr id="9" name="Rounded Rectangle 8"/>
+          <p:cNvSpPr/>
+          <p:nvPr/>
+        </p:nvSpPr>
+        <p:spPr>
+          <a:xfrm>
+            <a:off x="5760720" y="2560320"/>
+            <a:ext cx="2011680" cy="2194560"/>
           </a:xfrm>
           <a:prstGeom prst="roundRect">
             <a:avLst/>
@@ -8278,9 +8644,9 @@
           <a:p>
             <a:pPr algn="ctr">
               <a:spcAft>
-                <a:spcPts val="600"/>
+                <a:spcPts val="500"/>
               </a:spcAft>
-              <a:defRPr sz="1400" b="1">
+              <a:defRPr sz="1300" b="1">
                 <a:solidFill>
                   <a:srgbClr val="00B4D8"/>
                 </a:solidFill>
@@ -8288,12 +8654,12 @@
               </a:defRPr>
             </a:pPr>
             <a:r>
-              <a:t>Databricks Genie Ingestion</a:t>
+              <a:t>🔥 3. Verify Checkins</a:t>
             </a:r>
           </a:p>
           <a:p>
             <a:pPr>
-              <a:defRPr sz="1150">
+              <a:defRPr sz="1050">
                 <a:solidFill>
                   <a:srgbClr val="FFFFFF"/>
                 </a:solidFill>
@@ -8301,29 +8667,29 @@
               </a:defRPr>
             </a:pPr>
             <a:r>
-              <a:t>Firestore records -&gt; Syncs to GCS Bucket via Firebase Extension -&gt; Delta Lake mount -&gt; Databricks Genie query execution.</a:t>
-            </a:r>
-          </a:p>
-        </p:txBody>
-      </p:sp>
-      <p:sp>
-        <p:nvSpPr>
-          <p:cNvPr id="8" name="Rounded Rectangle 7"/>
+              <a:t>Firestore checks location data, stamps the student's Passport document, increments streaks, and unlocks map tiles.</a:t>
+            </a:r>
+          </a:p>
+        </p:txBody>
+      </p:sp>
+      <p:sp>
+        <p:nvSpPr>
+          <p:cNvPr id="10" name="Right Arrow 9"/>
           <p:cNvSpPr/>
           <p:nvPr/>
         </p:nvSpPr>
         <p:spPr>
           <a:xfrm>
-            <a:off x="6309360" y="1645920"/>
-            <a:ext cx="5120640" cy="4480560"/>
-          </a:xfrm>
-          <a:prstGeom prst="roundRect">
+            <a:off x="7772400" y="3429000"/>
+            <a:ext cx="502920" cy="457200"/>
+          </a:xfrm>
+          <a:prstGeom prst="rightArrow">
             <a:avLst/>
           </a:prstGeom>
           <a:solidFill>
-            <a:srgbClr val="101D30"/>
+            <a:srgbClr val="00B4D8"/>
           </a:solidFill>
-          <a:ln w="19050">
+          <a:ln w="12700">
             <a:solidFill>
               <a:srgbClr val="00B4D8"/>
             </a:solidFill>
@@ -8344,19 +8710,80 @@
           </a:fontRef>
         </p:style>
         <p:txBody>
-          <a:bodyPr rtlCol="0" anchor="ctr" wrap="square"/>
+          <a:bodyPr rtlCol="0" anchor="ctr"/>
+          <a:lstStyle/>
+          <a:p>
+            <a:pPr algn="ctr"/>
+          </a:p>
+        </p:txBody>
+      </p:sp>
+      <p:sp>
+        <p:nvSpPr>
+          <p:cNvPr id="11" name="Rounded Rectangle 10"/>
+          <p:cNvSpPr/>
+          <p:nvPr/>
+        </p:nvSpPr>
+        <p:spPr>
+          <a:xfrm>
+            <a:off x="8275320" y="3200400"/>
+            <a:ext cx="2560320" cy="2194560"/>
+          </a:xfrm>
+          <a:prstGeom prst="roundRect">
+            <a:avLst/>
+          </a:prstGeom>
+          <a:solidFill>
+            <a:srgbClr val="162438"/>
+          </a:solidFill>
+          <a:ln w="19050">
+            <a:solidFill>
+              <a:srgbClr val="263852"/>
+            </a:solidFill>
+          </a:ln>
+        </p:spPr>
+        <p:style>
+          <a:lnRef idx="1">
+            <a:schemeClr val="accent1"/>
+          </a:lnRef>
+          <a:fillRef idx="3">
+            <a:schemeClr val="accent1"/>
+          </a:fillRef>
+          <a:effectRef idx="2">
+            <a:schemeClr val="accent1"/>
+          </a:effectRef>
+          <a:fontRef idx="minor">
+            <a:schemeClr val="lt1"/>
+          </a:fontRef>
+        </p:style>
+        <p:txBody>
+          <a:bodyPr rtlCol="0" anchor="ctr" wrap="square" lIns="228600" rIns="228600" tIns="182880" bIns="182880"/>
           <a:lstStyle/>
           <a:p>
             <a:pPr algn="ctr">
-              <a:defRPr sz="1200" b="1">
-                <a:solidFill>
-                  <a:srgbClr val="BEC8DA"/>
-                </a:solidFill>
-                <a:latin typeface="Arial"/>
-              </a:defRPr>
-            </a:pPr>
-            <a:r>
-              <a:t>[ DIAGRAM: DATA SEQUENCE TRANSACTION FLOW ]</a:t>
+              <a:spcAft>
+                <a:spcPts val="500"/>
+              </a:spcAft>
+              <a:defRPr sz="1300" b="1">
+                <a:solidFill>
+                  <a:srgbClr val="00B4D8"/>
+                </a:solidFill>
+                <a:latin typeface="Arial"/>
+              </a:defRPr>
+            </a:pPr>
+            <a:r>
+              <a:t>🏆 4. Award XP</a:t>
+            </a:r>
+          </a:p>
+          <a:p>
+            <a:pPr>
+              <a:defRPr sz="1050">
+                <a:solidFill>
+                  <a:srgbClr val="FFFFFF"/>
+                </a:solidFill>
+                <a:latin typeface="Arial"/>
+              </a:defRPr>
+            </a:pPr>
+            <a:r>
+              <a:t>API calculates points (+120 XP for First-ever scan) and unlocks achievements, showing a Level-Up overlay on the phone screen.</a:t>
             </a:r>
           </a:p>
         </p:txBody>
@@ -8538,9 +8965,9 @@
           <a:p>
             <a:pPr algn="ctr">
               <a:spcAft>
-                <a:spcPts val="600"/>
+                <a:spcPts val="500"/>
               </a:spcAft>
-              <a:defRPr sz="1400" b="1">
+              <a:defRPr sz="1300" b="1">
                 <a:solidFill>
                   <a:srgbClr val="FFFFFF"/>
                 </a:solidFill>
@@ -8553,7 +8980,7 @@
           </a:p>
           <a:p>
             <a:pPr>
-              <a:defRPr sz="1150">
+              <a:defRPr sz="1050">
                 <a:solidFill>
                   <a:srgbClr val="FFFFFF"/>
                 </a:solidFill>
@@ -8630,9 +9057,9 @@
           <a:p>
             <a:pPr algn="ctr">
               <a:spcAft>
-                <a:spcPts val="600"/>
+                <a:spcPts val="500"/>
               </a:spcAft>
-              <a:defRPr sz="1400" b="1">
+              <a:defRPr sz="1300" b="1">
                 <a:solidFill>
                   <a:srgbClr val="FFFFFF"/>
                 </a:solidFill>
@@ -8645,7 +9072,7 @@
           </a:p>
           <a:p>
             <a:pPr>
-              <a:defRPr sz="1150">
+              <a:defRPr sz="1050">
                 <a:solidFill>
                   <a:srgbClr val="FFFFFF"/>
                 </a:solidFill>
@@ -8722,9 +9149,9 @@
           <a:p>
             <a:pPr algn="ctr">
               <a:spcAft>
-                <a:spcPts val="600"/>
+                <a:spcPts val="500"/>
               </a:spcAft>
-              <a:defRPr sz="1400" b="1">
+              <a:defRPr sz="1300" b="1">
                 <a:solidFill>
                   <a:srgbClr val="FFFFFF"/>
                 </a:solidFill>
@@ -8737,7 +9164,7 @@
           </a:p>
           <a:p>
             <a:pPr>
-              <a:defRPr sz="1150">
+              <a:defRPr sz="1050">
                 <a:solidFill>
                   <a:srgbClr val="FFFFFF"/>
                 </a:solidFill>

</xml_diff>